<commit_message>
Add live deployment URL to docs and deck
Co-Authored-By: Claude Opus 4.8 <noreply@anthropic.com>
</commit_message>
<xml_diff>
--- a/docs/AjaiaDocs-Walkthrough.pptx
+++ b/docs/AjaiaDocs-Walkthrough.pptx
@@ -8613,13 +8613,13 @@
             <a:r>
               <a:rPr lang="en-US" sz="1600" dirty="0">
                 <a:solidFill>
-                  <a:srgbClr val="C9C4E0"/>
-                </a:solidFill>
-                <a:latin typeface="Calibri" pitchFamily="34" charset="0"/>
-                <a:ea typeface="Calibri" pitchFamily="34" charset="-122"/>
-                <a:cs typeface="Calibri" pitchFamily="34" charset="-120"/>
-              </a:rPr>
-              <a:t>(add your Vercel URL)</a:t>
+                  <a:srgbClr val="FFFFFF"/>
+                </a:solidFill>
+                <a:latin typeface="Calibri" pitchFamily="34" charset="0"/>
+                <a:ea typeface="Calibri" pitchFamily="34" charset="-122"/>
+                <a:cs typeface="Calibri" pitchFamily="34" charset="-120"/>
+              </a:rPr>
+              <a:t>ajaia-three.vercel.app</a:t>
             </a:r>
             <a:endParaRPr lang="en-US" sz="1600" dirty="0"/>
           </a:p>

</xml_diff>